<commit_message>
Updates for S8 DA-V8
</commit_message>
<xml_diff>
--- a/08-da-v8-analizar-correlaciones/23-analisis-correlaciones.pptx
+++ b/08-da-v8-analizar-correlaciones/23-analisis-correlaciones.pptx
@@ -102,7 +102,7 @@
                 <a:tab algn="l" pos="0"/>
               </a:tabLst>
             </a:pPr>
-            <a:fld id="{20C245A0-472B-48FC-ACF4-4A12B061DE2B}" type="slidenum">
+            <a:fld id="{4F47C08A-D83E-4FA6-A5B6-4CCC343159F3}" type="slidenum">
               <a:rPr b="0" lang="en" sz="1000" strike="noStrike" u="none">
                 <a:solidFill>
                   <a:schemeClr val="dk2"/>
@@ -112,7 +112,7 @@
                 <a:latin typeface="Arial"/>
                 <a:ea typeface="Arial"/>
               </a:rPr>
-              <a:t>5</a:t>
+              <a:t>7</a:t>
             </a:fld>
             <a:endParaRPr b="0" lang="es-MX" sz="1000" strike="noStrike" u="none">
               <a:solidFill>
@@ -818,7 +818,7 @@
                 <a:tab algn="l" pos="0"/>
               </a:tabLst>
             </a:pPr>
-            <a:fld id="{D7DBEA86-6E3B-4557-8EED-00DD3511B715}" type="slidenum">
+            <a:fld id="{9C2C9923-E983-413D-820B-8E427ED62F48}" type="slidenum">
               <a:rPr b="0" lang="en" sz="1000" strike="noStrike" u="none">
                 <a:solidFill>
                   <a:schemeClr val="dk2"/>
@@ -2082,7 +2082,7 @@
                 <a:tab algn="l" pos="0"/>
               </a:tabLst>
             </a:pPr>
-            <a:fld id="{C6776F24-CA92-4C63-8BD7-35D8630B359D}" type="slidenum">
+            <a:fld id="{0902427C-8AED-4F27-A0E6-D04269B34628}" type="slidenum">
               <a:rPr b="0" lang="en" sz="1000" strike="noStrike" u="none">
                 <a:solidFill>
                   <a:schemeClr val="dk2"/>
@@ -3894,7 +3894,7 @@
                 <a:tab algn="l" pos="0"/>
               </a:tabLst>
             </a:pPr>
-            <a:fld id="{387DDD24-8E0F-44A5-81E9-977C510BC076}" type="slidenum">
+            <a:fld id="{BEC072EB-BE49-49CE-83E7-A40A4F297358}" type="slidenum">
               <a:rPr b="0" lang="en" sz="1000" strike="noStrike" u="none">
                 <a:solidFill>
                   <a:schemeClr val="dk2"/>
@@ -4003,7 +4003,7 @@
                 <a:tab algn="l" pos="0"/>
               </a:tabLst>
             </a:pPr>
-            <a:fld id="{3A0618EE-91BD-4AD5-8D35-E4C4C19801FD}" type="slidenum">
+            <a:fld id="{17299FC2-6DB0-42E0-99BD-7B4A556CC8B1}" type="slidenum">
               <a:rPr b="0" lang="en" sz="1000" strike="noStrike" u="none">
                 <a:solidFill>
                   <a:schemeClr val="dk2"/>
@@ -4504,7 +4504,7 @@
                 <a:tab algn="l" pos="0"/>
               </a:tabLst>
             </a:pPr>
-            <a:fld id="{66506F9F-9C6B-4B84-80F2-DB14327E7CC3}" type="slidenum">
+            <a:fld id="{E38BC435-05A9-42B7-BA99-B3D0BFBCDF47}" type="slidenum">
               <a:rPr b="0" lang="en" sz="1000" strike="noStrike" u="none">
                 <a:solidFill>
                   <a:schemeClr val="dk2"/>
@@ -4946,7 +4946,7 @@
                 <a:tab algn="l" pos="0"/>
               </a:tabLst>
             </a:pPr>
-            <a:fld id="{94A59493-FF51-4C91-BD0B-15D49FB94A88}" type="slidenum">
+            <a:fld id="{590B316A-0CC6-46AA-8829-31E10ACA5C93}" type="slidenum">
               <a:rPr b="0" lang="en" sz="1000" strike="noStrike" u="none">
                 <a:solidFill>
                   <a:schemeClr val="dk2"/>
@@ -5662,7 +5662,7 @@
                 <a:tab algn="l" pos="0"/>
               </a:tabLst>
             </a:pPr>
-            <a:fld id="{9D239F7B-F70E-4CD2-AEC7-DF8919D17060}" type="slidenum">
+            <a:fld id="{FF82F40C-8497-494A-A44B-AEAEC9EF5943}" type="slidenum">
               <a:rPr b="0" lang="en" sz="1000" strike="noStrike" u="none">
                 <a:solidFill>
                   <a:schemeClr val="dk2"/>
@@ -5830,7 +5830,7 @@
                 <a:tab algn="l" pos="0"/>
               </a:tabLst>
             </a:pPr>
-            <a:fld id="{30BFCCDD-CE32-4C9E-ABC8-39ECE6054B62}" type="slidenum">
+            <a:fld id="{8C79D436-7435-49CF-BFAC-0DA47D906149}" type="slidenum">
               <a:rPr b="0" lang="en" sz="1000" strike="noStrike" u="none">
                 <a:solidFill>
                   <a:schemeClr val="dk2"/>
@@ -5939,7 +5939,7 @@
                 <a:tab algn="l" pos="0"/>
               </a:tabLst>
             </a:pPr>
-            <a:fld id="{2A37D5BE-7970-445F-A1EB-27842554B163}" type="slidenum">
+            <a:fld id="{D7676E5E-9527-4F36-B98C-BFB6C74D7200}" type="slidenum">
               <a:rPr b="0" lang="en" sz="1000" strike="noStrike" u="none">
                 <a:solidFill>
                   <a:schemeClr val="dk2"/>
@@ -6929,7 +6929,7 @@
                 <a:tab algn="l" pos="0"/>
               </a:tabLst>
             </a:pPr>
-            <a:fld id="{4BD673BB-6F25-4E2A-A733-920BC599D2F8}" type="slidenum">
+            <a:fld id="{0575942E-D6A8-4A97-BDE6-322249F54791}" type="slidenum">
               <a:rPr b="0" lang="en" sz="1000" strike="noStrike" u="none">
                 <a:solidFill>
                   <a:schemeClr val="dk2"/>
@@ -7097,7 +7097,7 @@
                 <a:tab algn="l" pos="0"/>
               </a:tabLst>
             </a:pPr>
-            <a:fld id="{0DDC81BF-8CD8-4FE5-BF83-EEA78C994CB3}" type="slidenum">
+            <a:fld id="{82B86727-5C95-48EB-B891-9CCD9FA6B732}" type="slidenum">
               <a:rPr b="0" lang="en" sz="1000" strike="noStrike" u="none">
                 <a:solidFill>
                   <a:schemeClr val="dk2"/>
@@ -7107,7 +7107,7 @@
                 <a:latin typeface="Arial"/>
                 <a:ea typeface="Arial"/>
               </a:rPr>
-              <a:t>5</a:t>
+              <a:t>7</a:t>
             </a:fld>
             <a:endParaRPr b="0" lang="es-MX" sz="1000" strike="noStrike" u="none">
               <a:solidFill>
@@ -8087,7 +8087,7 @@
                 <a:tab algn="l" pos="0"/>
               </a:tabLst>
             </a:pPr>
-            <a:fld id="{5F4D8EC3-9A98-48BE-A593-F391D7D7580C}" type="slidenum">
+            <a:fld id="{850FF4CF-FD67-4609-A9C8-E72AA87442C3}" type="slidenum">
               <a:rPr b="0" lang="en" sz="1000" strike="noStrike" u="none">
                 <a:solidFill>
                   <a:schemeClr val="dk2"/>
@@ -9077,7 +9077,7 @@
                 <a:tab algn="l" pos="0"/>
               </a:tabLst>
             </a:pPr>
-            <a:fld id="{4CCA5677-3F74-4D04-B184-F8B42CA7E02A}" type="slidenum">
+            <a:fld id="{D926A8F7-698E-434B-AAD0-7F6EBF1E23BC}" type="slidenum">
               <a:rPr b="0" lang="en" sz="1000" strike="noStrike" u="none">
                 <a:solidFill>
                   <a:schemeClr val="dk2"/>
@@ -9793,7 +9793,7 @@
                 <a:tab algn="l" pos="0"/>
               </a:tabLst>
             </a:pPr>
-            <a:fld id="{DCAC5563-32D6-40B6-BF10-90C75FB332A9}" type="slidenum">
+            <a:fld id="{2F8280DE-CCA1-41C5-9240-ECCD7CF27F0E}" type="slidenum">
               <a:rPr b="0" lang="en" sz="1000" strike="noStrike" u="none">
                 <a:solidFill>
                   <a:schemeClr val="dk2"/>
@@ -11057,7 +11057,7 @@
                 <a:tab algn="l" pos="0"/>
               </a:tabLst>
             </a:pPr>
-            <a:fld id="{EF416785-772E-4BDE-BB8B-2A78B6CD92C7}" type="slidenum">
+            <a:fld id="{001052E9-0542-4D67-8F49-D5E19A2F5C86}" type="slidenum">
               <a:rPr b="0" lang="en" sz="1000" strike="noStrike" u="none">
                 <a:solidFill>
                   <a:schemeClr val="dk2"/>
@@ -12869,7 +12869,7 @@
                 <a:tab algn="l" pos="0"/>
               </a:tabLst>
             </a:pPr>
-            <a:fld id="{57764A05-E4B2-4F20-97BF-4DFEDD28FF84}" type="slidenum">
+            <a:fld id="{F145264C-59E0-4A9E-8CA5-6B35ED88AE18}" type="slidenum">
               <a:rPr b="0" lang="en" sz="1000" strike="noStrike" u="none">
                 <a:solidFill>
                   <a:schemeClr val="dk2"/>
@@ -12928,7 +12928,7 @@
         <p:txBody>
           <a:bodyPr/>
           <a:p>
-            <a:fld id="{FFE41836-488B-4AD8-8CCA-024F7EC2E975}" type="slidenum">
+            <a:fld id="{0C595D5A-5771-4D80-9069-F3061C75EE21}" type="slidenum">
               <a:t>&lt;#&gt;</a:t>
             </a:fld>
           </a:p>
@@ -12970,7 +12970,7 @@
         <p:txBody>
           <a:bodyPr/>
           <a:p>
-            <a:fld id="{7B3897A1-6FC8-429F-9A21-C2C3D802639B}" type="slidenum">
+            <a:fld id="{93499471-38BA-43F0-B3E4-DA1CA3199213}" type="slidenum">
               <a:t>&lt;#&gt;</a:t>
             </a:fld>
           </a:p>
@@ -13395,7 +13395,7 @@
                 <a:tab algn="l" pos="0"/>
               </a:tabLst>
             </a:pPr>
-            <a:fld id="{AE2B34FC-C59C-4647-8239-C7DFBEFB1629}" type="slidenum">
+            <a:fld id="{385E9546-4FE6-48F5-AAF2-C973BEE8E085}" type="slidenum">
               <a:rPr b="0" lang="en" sz="1000" strike="noStrike" u="none">
                 <a:solidFill>
                   <a:schemeClr val="dk2"/>
@@ -14111,7 +14111,7 @@
                 <a:tab algn="l" pos="0"/>
               </a:tabLst>
             </a:pPr>
-            <a:fld id="{765EF191-92D0-477E-88E3-EC02DA5AEBD3}" type="slidenum">
+            <a:fld id="{0CC0105E-2254-4188-9A5E-5437082E691C}" type="slidenum">
               <a:rPr b="0" lang="en" sz="1000" strike="noStrike" u="none">
                 <a:solidFill>
                   <a:schemeClr val="dk2"/>
@@ -14279,7 +14279,7 @@
                 <a:tab algn="l" pos="0"/>
               </a:tabLst>
             </a:pPr>
-            <a:fld id="{019AD42C-F7E1-4957-A38C-6F98F5D230FC}" type="slidenum">
+            <a:fld id="{01FC56FE-018C-4E6E-ACF0-10BF2378AA68}" type="slidenum">
               <a:rPr b="0" lang="en" sz="1000" strike="noStrike" u="none">
                 <a:solidFill>
                   <a:schemeClr val="dk2"/>
@@ -14388,7 +14388,7 @@
                 <a:tab algn="l" pos="0"/>
               </a:tabLst>
             </a:pPr>
-            <a:fld id="{ACBBF0F9-F602-4D37-9939-D608B8AE3276}" type="slidenum">
+            <a:fld id="{942A1046-7367-4E10-8E65-98F787363FA2}" type="slidenum">
               <a:rPr b="0" lang="en" sz="1000" strike="noStrike" u="none">
                 <a:solidFill>
                   <a:schemeClr val="dk2"/>
@@ -15378,7 +15378,7 @@
                 <a:tab algn="l" pos="0"/>
               </a:tabLst>
             </a:pPr>
-            <a:fld id="{906ABFBD-DB83-4E26-BD3C-F584CA05614E}" type="slidenum">
+            <a:fld id="{36E0AD6C-CD1A-49F1-8D55-15623C519513}" type="slidenum">
               <a:rPr b="0" lang="en" sz="1000" strike="noStrike" u="none">
                 <a:solidFill>
                   <a:schemeClr val="dk2"/>
@@ -16368,7 +16368,7 @@
                 <a:tab algn="l" pos="0"/>
               </a:tabLst>
             </a:pPr>
-            <a:fld id="{0FB5842A-AE8F-4ED3-98AD-ABAE373FA5D7}" type="slidenum">
+            <a:fld id="{F003021C-571C-4D83-8C95-7FEF51E8E422}" type="slidenum">
               <a:rPr b="0" lang="en" sz="1000" strike="noStrike" u="none">
                 <a:solidFill>
                   <a:schemeClr val="dk2"/>
@@ -17358,7 +17358,7 @@
                 <a:tab algn="l" pos="0"/>
               </a:tabLst>
             </a:pPr>
-            <a:fld id="{5F91BFA4-BB06-48FC-9858-7FDA23D00B5A}" type="slidenum">
+            <a:fld id="{2544CD29-42DD-493D-A8BE-5718C35BF697}" type="slidenum">
               <a:rPr b="0" lang="en" sz="1000" strike="noStrike" u="none">
                 <a:solidFill>
                   <a:schemeClr val="dk2"/>
@@ -17541,7 +17541,7 @@
                 <a:tab algn="l" pos="0"/>
               </a:tabLst>
             </a:pPr>
-            <a:fld id="{80F1AEA0-9BC7-40EC-9A2C-1991981581ED}" type="slidenum">
+            <a:fld id="{7423A9A9-9A99-4434-807F-E5D8AA8368EB}" type="slidenum">
               <a:rPr b="0" lang="en" sz="1000" strike="noStrike" u="none">
                 <a:solidFill>
                   <a:schemeClr val="dk2"/>
@@ -17960,7 +17960,7 @@
                 <a:tab algn="l" pos="0"/>
               </a:tabLst>
             </a:pPr>
-            <a:fld id="{5A51F9CE-5B72-4E49-B80E-B392085FFEA7}" type="slidenum">
+            <a:fld id="{65AE0A8B-2ACC-4026-BA49-20076FBDA2A5}" type="slidenum">
               <a:rPr b="0" lang="en" sz="1000" strike="noStrike" u="none">
                 <a:solidFill>
                   <a:schemeClr val="dk2"/>
@@ -17970,7 +17970,7 @@
                 <a:latin typeface="Arial"/>
                 <a:ea typeface="Arial"/>
               </a:rPr>
-              <a:t>&lt;número&gt;</a:t>
+              <a:t>1</a:t>
             </a:fld>
             <a:endParaRPr b="0" lang="es-MX" sz="1000" strike="noStrike" u="none">
               <a:solidFill>
@@ -18460,7 +18460,7 @@
                 <a:tab algn="l" pos="0"/>
               </a:tabLst>
             </a:pPr>
-            <a:fld id="{6670D4C2-09C1-4A33-B1E2-E588142F7BCA}" type="datetime5">
+            <a:fld id="{9A8FDCE9-E450-4A75-AF9E-2183307E516D}" type="datetime5">
               <a:rPr b="0" lang="en" sz="1200" strike="noStrike" u="none">
                 <a:solidFill>
                   <a:srgbClr val="2a2a2a"/>
@@ -18470,7 +18470,7 @@
                 <a:latin typeface="Inter Medium"/>
                 <a:ea typeface="Inter Medium"/>
               </a:rPr>
-              <a:t>Jan 15, 2026</a:t>
+              <a:t>Jan 16, 2026</a:t>
             </a:fld>
             <a:endParaRPr b="0" lang="es-MX" sz="1200" strike="noStrike" u="none">
               <a:solidFill>

</xml_diff>